<commit_message>
Update presentation slides with screenshots and callouts
Co-Authored-By: Claude Opus 4.6 <noreply@anthropic.com>
</commit_message>
<xml_diff>
--- a/docs/slides.pptx
+++ b/docs/slides.pptx
@@ -5,13 +5,13 @@
     <p:sldMasterId id="2147483648" r:id="rId1"/>
   </p:sldMasterIdLst>
   <p:sldIdLst>
-    <p:sldId id="256" r:id="rId7"/>
-    <p:sldId id="257" r:id="rId8"/>
-    <p:sldId id="258" r:id="rId9"/>
-    <p:sldId id="259" r:id="rId10"/>
-    <p:sldId id="260" r:id="rId11"/>
+    <p:sldId id="256" r:id="rId2"/>
+    <p:sldId id="257" r:id="rId3"/>
+    <p:sldId id="258" r:id="rId4"/>
+    <p:sldId id="259" r:id="rId5"/>
+    <p:sldId id="260" r:id="rId6"/>
   </p:sldIdLst>
-  <p:sldSz cx="12191695" cy="6858000" type="screen4x3"/>
+  <p:sldSz cx="12192000" cy="6858000"/>
   <p:notesSz cx="6858000" cy="9144000"/>
   <p:defaultTextStyle>
     <a:defPPr>
@@ -108,6 +108,22 @@
       </a:defRPr>
     </a:lvl9pPr>
   </p:defaultTextStyle>
+  <p:extLst>
+    <p:ext uri="{EFAFB233-063F-42B5-8137-9DF3F51BA10A}">
+      <p15:sldGuideLst xmlns:p15="http://schemas.microsoft.com/office/powerpoint/2012/main">
+        <p15:guide id="1" orient="horz" pos="2160">
+          <p15:clr>
+            <a:srgbClr val="A4A3A4"/>
+          </p15:clr>
+        </p15:guide>
+        <p15:guide id="2" pos="2880">
+          <p15:clr>
+            <a:srgbClr val="A4A3A4"/>
+          </p15:clr>
+        </p15:guide>
+      </p15:sldGuideLst>
+    </p:ext>
+  </p:extLst>
 </p:presentation>
 </file>
 
@@ -149,10 +165,9 @@
           <a:lstStyle/>
           <a:p>
             <a:r>
-              <a:rPr lang="en-US" smtClean="0"/>
+              <a:rPr lang="en-US"/>
               <a:t>Click to edit Master title style</a:t>
             </a:r>
-            <a:endParaRPr lang="en-US"/>
           </a:p>
         </p:txBody>
       </p:sp>
@@ -268,10 +283,9 @@
           </a:lstStyle>
           <a:p>
             <a:r>
-              <a:rPr lang="en-US" smtClean="0"/>
+              <a:rPr lang="en-US"/>
               <a:t>Click to edit Master subtitle style</a:t>
             </a:r>
-            <a:endParaRPr lang="en-US"/>
           </a:p>
         </p:txBody>
       </p:sp>
@@ -292,7 +306,7 @@
           <a:p>
             <a:fld id="{5BCAD085-E8A6-8845-BD4E-CB4CCA059FC4}" type="datetimeFigureOut">
               <a:rPr lang="en-US" smtClean="0"/>
-              <a:t>1/27/13</a:t>
+              <a:t>5/4/26</a:t>
             </a:fld>
             <a:endParaRPr lang="en-US"/>
           </a:p>
@@ -386,10 +400,9 @@
           <a:lstStyle/>
           <a:p>
             <a:r>
-              <a:rPr lang="en-US" smtClean="0"/>
+              <a:rPr lang="en-US"/>
               <a:t>Click to edit Master title style</a:t>
             </a:r>
-            <a:endParaRPr lang="en-US"/>
           </a:p>
         </p:txBody>
       </p:sp>
@@ -410,38 +423,37 @@
           <a:p>
             <a:pPr lvl="0"/>
             <a:r>
-              <a:rPr lang="en-US" smtClean="0"/>
+              <a:rPr lang="en-US"/>
               <a:t>Click to edit Master text styles</a:t>
             </a:r>
           </a:p>
           <a:p>
             <a:pPr lvl="1"/>
             <a:r>
-              <a:rPr lang="en-US" smtClean="0"/>
+              <a:rPr lang="en-US"/>
               <a:t>Second level</a:t>
             </a:r>
           </a:p>
           <a:p>
             <a:pPr lvl="2"/>
             <a:r>
-              <a:rPr lang="en-US" smtClean="0"/>
+              <a:rPr lang="en-US"/>
               <a:t>Third level</a:t>
             </a:r>
           </a:p>
           <a:p>
             <a:pPr lvl="3"/>
             <a:r>
-              <a:rPr lang="en-US" smtClean="0"/>
+              <a:rPr lang="en-US"/>
               <a:t>Fourth level</a:t>
             </a:r>
           </a:p>
           <a:p>
             <a:pPr lvl="4"/>
             <a:r>
-              <a:rPr lang="en-US" smtClean="0"/>
+              <a:rPr lang="en-US"/>
               <a:t>Fifth level</a:t>
             </a:r>
-            <a:endParaRPr lang="en-US"/>
           </a:p>
         </p:txBody>
       </p:sp>
@@ -462,7 +474,7 @@
           <a:p>
             <a:fld id="{5BCAD085-E8A6-8845-BD4E-CB4CCA059FC4}" type="datetimeFigureOut">
               <a:rPr lang="en-US" smtClean="0"/>
-              <a:t>1/27/13</a:t>
+              <a:t>5/4/26</a:t>
             </a:fld>
             <a:endParaRPr lang="en-US"/>
           </a:p>
@@ -561,10 +573,9 @@
           <a:lstStyle/>
           <a:p>
             <a:r>
-              <a:rPr lang="en-US" smtClean="0"/>
+              <a:rPr lang="en-US"/>
               <a:t>Click to edit Master title style</a:t>
             </a:r>
-            <a:endParaRPr lang="en-US"/>
           </a:p>
         </p:txBody>
       </p:sp>
@@ -590,38 +601,37 @@
           <a:p>
             <a:pPr lvl="0"/>
             <a:r>
-              <a:rPr lang="en-US" smtClean="0"/>
+              <a:rPr lang="en-US"/>
               <a:t>Click to edit Master text styles</a:t>
             </a:r>
           </a:p>
           <a:p>
             <a:pPr lvl="1"/>
             <a:r>
-              <a:rPr lang="en-US" smtClean="0"/>
+              <a:rPr lang="en-US"/>
               <a:t>Second level</a:t>
             </a:r>
           </a:p>
           <a:p>
             <a:pPr lvl="2"/>
             <a:r>
-              <a:rPr lang="en-US" smtClean="0"/>
+              <a:rPr lang="en-US"/>
               <a:t>Third level</a:t>
             </a:r>
           </a:p>
           <a:p>
             <a:pPr lvl="3"/>
             <a:r>
-              <a:rPr lang="en-US" smtClean="0"/>
+              <a:rPr lang="en-US"/>
               <a:t>Fourth level</a:t>
             </a:r>
           </a:p>
           <a:p>
             <a:pPr lvl="4"/>
             <a:r>
-              <a:rPr lang="en-US" smtClean="0"/>
+              <a:rPr lang="en-US"/>
               <a:t>Fifth level</a:t>
             </a:r>
-            <a:endParaRPr lang="en-US"/>
           </a:p>
         </p:txBody>
       </p:sp>
@@ -642,7 +652,7 @@
           <a:p>
             <a:fld id="{5BCAD085-E8A6-8845-BD4E-CB4CCA059FC4}" type="datetimeFigureOut">
               <a:rPr lang="en-US" smtClean="0"/>
-              <a:t>1/27/13</a:t>
+              <a:t>5/4/26</a:t>
             </a:fld>
             <a:endParaRPr lang="en-US"/>
           </a:p>
@@ -736,10 +746,9 @@
           <a:lstStyle/>
           <a:p>
             <a:r>
-              <a:rPr lang="en-US" smtClean="0"/>
+              <a:rPr lang="en-US"/>
               <a:t>Click to edit Master title style</a:t>
             </a:r>
-            <a:endParaRPr lang="en-US"/>
           </a:p>
         </p:txBody>
       </p:sp>
@@ -760,38 +769,37 @@
           <a:p>
             <a:pPr lvl="0"/>
             <a:r>
-              <a:rPr lang="en-US" smtClean="0"/>
+              <a:rPr lang="en-US"/>
               <a:t>Click to edit Master text styles</a:t>
             </a:r>
           </a:p>
           <a:p>
             <a:pPr lvl="1"/>
             <a:r>
-              <a:rPr lang="en-US" smtClean="0"/>
+              <a:rPr lang="en-US"/>
               <a:t>Second level</a:t>
             </a:r>
           </a:p>
           <a:p>
             <a:pPr lvl="2"/>
             <a:r>
-              <a:rPr lang="en-US" smtClean="0"/>
+              <a:rPr lang="en-US"/>
               <a:t>Third level</a:t>
             </a:r>
           </a:p>
           <a:p>
             <a:pPr lvl="3"/>
             <a:r>
-              <a:rPr lang="en-US" smtClean="0"/>
+              <a:rPr lang="en-US"/>
               <a:t>Fourth level</a:t>
             </a:r>
           </a:p>
           <a:p>
             <a:pPr lvl="4"/>
             <a:r>
-              <a:rPr lang="en-US" smtClean="0"/>
+              <a:rPr lang="en-US"/>
               <a:t>Fifth level</a:t>
             </a:r>
-            <a:endParaRPr lang="en-US"/>
           </a:p>
         </p:txBody>
       </p:sp>
@@ -812,7 +820,7 @@
           <a:p>
             <a:fld id="{5BCAD085-E8A6-8845-BD4E-CB4CCA059FC4}" type="datetimeFigureOut">
               <a:rPr lang="en-US" smtClean="0"/>
-              <a:t>1/27/13</a:t>
+              <a:t>5/4/26</a:t>
             </a:fld>
             <a:endParaRPr lang="en-US"/>
           </a:p>
@@ -915,10 +923,9 @@
           </a:lstStyle>
           <a:p>
             <a:r>
-              <a:rPr lang="en-US" smtClean="0"/>
+              <a:rPr lang="en-US"/>
               <a:t>Click to edit Master title style</a:t>
             </a:r>
-            <a:endParaRPr lang="en-US"/>
           </a:p>
         </p:txBody>
       </p:sp>
@@ -1035,7 +1042,7 @@
           <a:p>
             <a:pPr lvl="0"/>
             <a:r>
-              <a:rPr lang="en-US" smtClean="0"/>
+              <a:rPr lang="en-US"/>
               <a:t>Click to edit Master text styles</a:t>
             </a:r>
           </a:p>
@@ -1058,7 +1065,7 @@
           <a:p>
             <a:fld id="{5BCAD085-E8A6-8845-BD4E-CB4CCA059FC4}" type="datetimeFigureOut">
               <a:rPr lang="en-US" smtClean="0"/>
-              <a:t>1/27/13</a:t>
+              <a:t>5/4/26</a:t>
             </a:fld>
             <a:endParaRPr lang="en-US"/>
           </a:p>
@@ -1152,10 +1159,9 @@
           <a:lstStyle/>
           <a:p>
             <a:r>
-              <a:rPr lang="en-US" smtClean="0"/>
+              <a:rPr lang="en-US"/>
               <a:t>Click to edit Master title style</a:t>
             </a:r>
-            <a:endParaRPr lang="en-US"/>
           </a:p>
         </p:txBody>
       </p:sp>
@@ -1209,38 +1215,37 @@
           <a:p>
             <a:pPr lvl="0"/>
             <a:r>
-              <a:rPr lang="en-US" smtClean="0"/>
+              <a:rPr lang="en-US"/>
               <a:t>Click to edit Master text styles</a:t>
             </a:r>
           </a:p>
           <a:p>
             <a:pPr lvl="1"/>
             <a:r>
-              <a:rPr lang="en-US" smtClean="0"/>
+              <a:rPr lang="en-US"/>
               <a:t>Second level</a:t>
             </a:r>
           </a:p>
           <a:p>
             <a:pPr lvl="2"/>
             <a:r>
-              <a:rPr lang="en-US" smtClean="0"/>
+              <a:rPr lang="en-US"/>
               <a:t>Third level</a:t>
             </a:r>
           </a:p>
           <a:p>
             <a:pPr lvl="3"/>
             <a:r>
-              <a:rPr lang="en-US" smtClean="0"/>
+              <a:rPr lang="en-US"/>
               <a:t>Fourth level</a:t>
             </a:r>
           </a:p>
           <a:p>
             <a:pPr lvl="4"/>
             <a:r>
-              <a:rPr lang="en-US" smtClean="0"/>
+              <a:rPr lang="en-US"/>
               <a:t>Fifth level</a:t>
             </a:r>
-            <a:endParaRPr lang="en-US"/>
           </a:p>
         </p:txBody>
       </p:sp>
@@ -1294,38 +1299,37 @@
           <a:p>
             <a:pPr lvl="0"/>
             <a:r>
-              <a:rPr lang="en-US" smtClean="0"/>
+              <a:rPr lang="en-US"/>
               <a:t>Click to edit Master text styles</a:t>
             </a:r>
           </a:p>
           <a:p>
             <a:pPr lvl="1"/>
             <a:r>
-              <a:rPr lang="en-US" smtClean="0"/>
+              <a:rPr lang="en-US"/>
               <a:t>Second level</a:t>
             </a:r>
           </a:p>
           <a:p>
             <a:pPr lvl="2"/>
             <a:r>
-              <a:rPr lang="en-US" smtClean="0"/>
+              <a:rPr lang="en-US"/>
               <a:t>Third level</a:t>
             </a:r>
           </a:p>
           <a:p>
             <a:pPr lvl="3"/>
             <a:r>
-              <a:rPr lang="en-US" smtClean="0"/>
+              <a:rPr lang="en-US"/>
               <a:t>Fourth level</a:t>
             </a:r>
           </a:p>
           <a:p>
             <a:pPr lvl="4"/>
             <a:r>
-              <a:rPr lang="en-US" smtClean="0"/>
+              <a:rPr lang="en-US"/>
               <a:t>Fifth level</a:t>
             </a:r>
-            <a:endParaRPr lang="en-US"/>
           </a:p>
         </p:txBody>
       </p:sp>
@@ -1346,7 +1350,7 @@
           <a:p>
             <a:fld id="{5BCAD085-E8A6-8845-BD4E-CB4CCA059FC4}" type="datetimeFigureOut">
               <a:rPr lang="en-US" smtClean="0"/>
-              <a:t>1/27/13</a:t>
+              <a:t>5/4/26</a:t>
             </a:fld>
             <a:endParaRPr lang="en-US"/>
           </a:p>
@@ -1444,10 +1448,9 @@
           </a:lstStyle>
           <a:p>
             <a:r>
-              <a:rPr lang="en-US" smtClean="0"/>
+              <a:rPr lang="en-US"/>
               <a:t>Click to edit Master title style</a:t>
             </a:r>
-            <a:endParaRPr lang="en-US"/>
           </a:p>
         </p:txBody>
       </p:sp>
@@ -1510,7 +1513,7 @@
           <a:p>
             <a:pPr lvl="0"/>
             <a:r>
-              <a:rPr lang="en-US" smtClean="0"/>
+              <a:rPr lang="en-US"/>
               <a:t>Click to edit Master text styles</a:t>
             </a:r>
           </a:p>
@@ -1566,38 +1569,37 @@
           <a:p>
             <a:pPr lvl="0"/>
             <a:r>
-              <a:rPr lang="en-US" smtClean="0"/>
+              <a:rPr lang="en-US"/>
               <a:t>Click to edit Master text styles</a:t>
             </a:r>
           </a:p>
           <a:p>
             <a:pPr lvl="1"/>
             <a:r>
-              <a:rPr lang="en-US" smtClean="0"/>
+              <a:rPr lang="en-US"/>
               <a:t>Second level</a:t>
             </a:r>
           </a:p>
           <a:p>
             <a:pPr lvl="2"/>
             <a:r>
-              <a:rPr lang="en-US" smtClean="0"/>
+              <a:rPr lang="en-US"/>
               <a:t>Third level</a:t>
             </a:r>
           </a:p>
           <a:p>
             <a:pPr lvl="3"/>
             <a:r>
-              <a:rPr lang="en-US" smtClean="0"/>
+              <a:rPr lang="en-US"/>
               <a:t>Fourth level</a:t>
             </a:r>
           </a:p>
           <a:p>
             <a:pPr lvl="4"/>
             <a:r>
-              <a:rPr lang="en-US" smtClean="0"/>
+              <a:rPr lang="en-US"/>
               <a:t>Fifth level</a:t>
             </a:r>
-            <a:endParaRPr lang="en-US"/>
           </a:p>
         </p:txBody>
       </p:sp>
@@ -1660,7 +1662,7 @@
           <a:p>
             <a:pPr lvl="0"/>
             <a:r>
-              <a:rPr lang="en-US" smtClean="0"/>
+              <a:rPr lang="en-US"/>
               <a:t>Click to edit Master text styles</a:t>
             </a:r>
           </a:p>
@@ -1716,38 +1718,37 @@
           <a:p>
             <a:pPr lvl="0"/>
             <a:r>
-              <a:rPr lang="en-US" smtClean="0"/>
+              <a:rPr lang="en-US"/>
               <a:t>Click to edit Master text styles</a:t>
             </a:r>
           </a:p>
           <a:p>
             <a:pPr lvl="1"/>
             <a:r>
-              <a:rPr lang="en-US" smtClean="0"/>
+              <a:rPr lang="en-US"/>
               <a:t>Second level</a:t>
             </a:r>
           </a:p>
           <a:p>
             <a:pPr lvl="2"/>
             <a:r>
-              <a:rPr lang="en-US" smtClean="0"/>
+              <a:rPr lang="en-US"/>
               <a:t>Third level</a:t>
             </a:r>
           </a:p>
           <a:p>
             <a:pPr lvl="3"/>
             <a:r>
-              <a:rPr lang="en-US" smtClean="0"/>
+              <a:rPr lang="en-US"/>
               <a:t>Fourth level</a:t>
             </a:r>
           </a:p>
           <a:p>
             <a:pPr lvl="4"/>
             <a:r>
-              <a:rPr lang="en-US" smtClean="0"/>
+              <a:rPr lang="en-US"/>
               <a:t>Fifth level</a:t>
             </a:r>
-            <a:endParaRPr lang="en-US"/>
           </a:p>
         </p:txBody>
       </p:sp>
@@ -1768,7 +1769,7 @@
           <a:p>
             <a:fld id="{5BCAD085-E8A6-8845-BD4E-CB4CCA059FC4}" type="datetimeFigureOut">
               <a:rPr lang="en-US" smtClean="0"/>
-              <a:t>1/27/13</a:t>
+              <a:t>5/4/26</a:t>
             </a:fld>
             <a:endParaRPr lang="en-US"/>
           </a:p>
@@ -1862,10 +1863,9 @@
           <a:lstStyle/>
           <a:p>
             <a:r>
-              <a:rPr lang="en-US" smtClean="0"/>
+              <a:rPr lang="en-US"/>
               <a:t>Click to edit Master title style</a:t>
             </a:r>
-            <a:endParaRPr lang="en-US"/>
           </a:p>
         </p:txBody>
       </p:sp>
@@ -1886,7 +1886,7 @@
           <a:p>
             <a:fld id="{5BCAD085-E8A6-8845-BD4E-CB4CCA059FC4}" type="datetimeFigureOut">
               <a:rPr lang="en-US" smtClean="0"/>
-              <a:t>1/27/13</a:t>
+              <a:t>5/4/26</a:t>
             </a:fld>
             <a:endParaRPr lang="en-US"/>
           </a:p>
@@ -1981,7 +1981,7 @@
           <a:p>
             <a:fld id="{5BCAD085-E8A6-8845-BD4E-CB4CCA059FC4}" type="datetimeFigureOut">
               <a:rPr lang="en-US" smtClean="0"/>
-              <a:t>1/27/13</a:t>
+              <a:t>5/4/26</a:t>
             </a:fld>
             <a:endParaRPr lang="en-US"/>
           </a:p>
@@ -2084,10 +2084,9 @@
           </a:lstStyle>
           <a:p>
             <a:r>
-              <a:rPr lang="en-US" smtClean="0"/>
+              <a:rPr lang="en-US"/>
               <a:t>Click to edit Master title style</a:t>
             </a:r>
-            <a:endParaRPr lang="en-US"/>
           </a:p>
         </p:txBody>
       </p:sp>
@@ -2141,38 +2140,37 @@
           <a:p>
             <a:pPr lvl="0"/>
             <a:r>
-              <a:rPr lang="en-US" smtClean="0"/>
+              <a:rPr lang="en-US"/>
               <a:t>Click to edit Master text styles</a:t>
             </a:r>
           </a:p>
           <a:p>
             <a:pPr lvl="1"/>
             <a:r>
-              <a:rPr lang="en-US" smtClean="0"/>
+              <a:rPr lang="en-US"/>
               <a:t>Second level</a:t>
             </a:r>
           </a:p>
           <a:p>
             <a:pPr lvl="2"/>
             <a:r>
-              <a:rPr lang="en-US" smtClean="0"/>
+              <a:rPr lang="en-US"/>
               <a:t>Third level</a:t>
             </a:r>
           </a:p>
           <a:p>
             <a:pPr lvl="3"/>
             <a:r>
-              <a:rPr lang="en-US" smtClean="0"/>
+              <a:rPr lang="en-US"/>
               <a:t>Fourth level</a:t>
             </a:r>
           </a:p>
           <a:p>
             <a:pPr lvl="4"/>
             <a:r>
-              <a:rPr lang="en-US" smtClean="0"/>
+              <a:rPr lang="en-US"/>
               <a:t>Fifth level</a:t>
             </a:r>
-            <a:endParaRPr lang="en-US"/>
           </a:p>
         </p:txBody>
       </p:sp>
@@ -2235,7 +2233,7 @@
           <a:p>
             <a:pPr lvl="0"/>
             <a:r>
-              <a:rPr lang="en-US" smtClean="0"/>
+              <a:rPr lang="en-US"/>
               <a:t>Click to edit Master text styles</a:t>
             </a:r>
           </a:p>
@@ -2258,7 +2256,7 @@
           <a:p>
             <a:fld id="{5BCAD085-E8A6-8845-BD4E-CB4CCA059FC4}" type="datetimeFigureOut">
               <a:rPr lang="en-US" smtClean="0"/>
-              <a:t>1/27/13</a:t>
+              <a:t>5/4/26</a:t>
             </a:fld>
             <a:endParaRPr lang="en-US"/>
           </a:p>
@@ -2361,10 +2359,9 @@
           </a:lstStyle>
           <a:p>
             <a:r>
-              <a:rPr lang="en-US" smtClean="0"/>
+              <a:rPr lang="en-US"/>
               <a:t>Click to edit Master title style</a:t>
             </a:r>
-            <a:endParaRPr lang="en-US"/>
           </a:p>
         </p:txBody>
       </p:sp>
@@ -2488,7 +2485,7 @@
           <a:p>
             <a:pPr lvl="0"/>
             <a:r>
-              <a:rPr lang="en-US" smtClean="0"/>
+              <a:rPr lang="en-US"/>
               <a:t>Click to edit Master text styles</a:t>
             </a:r>
           </a:p>
@@ -2511,7 +2508,7 @@
           <a:p>
             <a:fld id="{5BCAD085-E8A6-8845-BD4E-CB4CCA059FC4}" type="datetimeFigureOut">
               <a:rPr lang="en-US" smtClean="0"/>
-              <a:t>1/27/13</a:t>
+              <a:t>5/4/26</a:t>
             </a:fld>
             <a:endParaRPr lang="en-US"/>
           </a:p>
@@ -2620,10 +2617,9 @@
           <a:lstStyle/>
           <a:p>
             <a:r>
-              <a:rPr lang="en-US" smtClean="0"/>
+              <a:rPr lang="en-US"/>
               <a:t>Click to edit Master title style</a:t>
             </a:r>
-            <a:endParaRPr lang="en-US"/>
           </a:p>
         </p:txBody>
       </p:sp>
@@ -2654,38 +2650,37 @@
           <a:p>
             <a:pPr lvl="0"/>
             <a:r>
-              <a:rPr lang="en-US" smtClean="0"/>
+              <a:rPr lang="en-US"/>
               <a:t>Click to edit Master text styles</a:t>
             </a:r>
           </a:p>
           <a:p>
             <a:pPr lvl="1"/>
             <a:r>
-              <a:rPr lang="en-US" smtClean="0"/>
+              <a:rPr lang="en-US"/>
               <a:t>Second level</a:t>
             </a:r>
           </a:p>
           <a:p>
             <a:pPr lvl="2"/>
             <a:r>
-              <a:rPr lang="en-US" smtClean="0"/>
+              <a:rPr lang="en-US"/>
               <a:t>Third level</a:t>
             </a:r>
           </a:p>
           <a:p>
             <a:pPr lvl="3"/>
             <a:r>
-              <a:rPr lang="en-US" smtClean="0"/>
+              <a:rPr lang="en-US"/>
               <a:t>Fourth level</a:t>
             </a:r>
           </a:p>
           <a:p>
             <a:pPr lvl="4"/>
             <a:r>
-              <a:rPr lang="en-US" smtClean="0"/>
+              <a:rPr lang="en-US"/>
               <a:t>Fifth level</a:t>
             </a:r>
-            <a:endParaRPr lang="en-US"/>
           </a:p>
         </p:txBody>
       </p:sp>
@@ -2724,7 +2719,7 @@
           <a:p>
             <a:fld id="{5BCAD085-E8A6-8845-BD4E-CB4CCA059FC4}" type="datetimeFigureOut">
               <a:rPr lang="en-US" smtClean="0"/>
-              <a:t>1/27/13</a:t>
+              <a:t>5/4/26</a:t>
             </a:fld>
             <a:endParaRPr lang="en-US"/>
           </a:p>
@@ -3083,7 +3078,7 @@
 </file>
 
 <file path=ppt/slides/slide1.xml><?xml version="1.0" encoding="utf-8"?>
-<p:sld xmlns:a="http://schemas.openxmlformats.org/drawingml/2006/main" xmlns:p="http://schemas.openxmlformats.org/presentationml/2006/main" xmlns:r="http://schemas.openxmlformats.org/officeDocument/2006/relationships">
+<p:sld xmlns:a="http://schemas.openxmlformats.org/drawingml/2006/main" xmlns:r="http://schemas.openxmlformats.org/officeDocument/2006/relationships" xmlns:p="http://schemas.openxmlformats.org/presentationml/2006/main">
   <p:cSld>
     <p:bg>
       <p:bgPr>
@@ -3099,7 +3094,14 @@
         <p:cNvGrpSpPr/>
         <p:nvPr/>
       </p:nvGrpSpPr>
-      <p:grpSpPr/>
+      <p:grpSpPr>
+        <a:xfrm>
+          <a:off x="0" y="0"/>
+          <a:ext cx="0" cy="0"/>
+          <a:chOff x="0" y="0"/>
+          <a:chExt cx="0" cy="0"/>
+        </a:xfrm>
+      </p:grpSpPr>
       <p:sp>
         <p:nvSpPr>
           <p:cNvPr id="2" name="TextBox 1"/>
@@ -3253,7 +3255,7 @@
 </file>
 
 <file path=ppt/slides/slide2.xml><?xml version="1.0" encoding="utf-8"?>
-<p:sld xmlns:a="http://schemas.openxmlformats.org/drawingml/2006/main" xmlns:p="http://schemas.openxmlformats.org/presentationml/2006/main" xmlns:r="http://schemas.openxmlformats.org/officeDocument/2006/relationships">
+<p:sld xmlns:a="http://schemas.openxmlformats.org/drawingml/2006/main" xmlns:r="http://schemas.openxmlformats.org/officeDocument/2006/relationships" xmlns:p="http://schemas.openxmlformats.org/presentationml/2006/main">
   <p:cSld>
     <p:bg>
       <p:bgPr>
@@ -3269,7 +3271,14 @@
         <p:cNvGrpSpPr/>
         <p:nvPr/>
       </p:nvGrpSpPr>
-      <p:grpSpPr/>
+      <p:grpSpPr>
+        <a:xfrm>
+          <a:off x="0" y="0"/>
+          <a:ext cx="0" cy="0"/>
+          <a:chOff x="0" y="0"/>
+          <a:chExt cx="0" cy="0"/>
+        </a:xfrm>
+      </p:grpSpPr>
       <p:sp>
         <p:nvSpPr>
           <p:cNvPr id="2" name="TextBox 1"/>
@@ -3300,6 +3309,7 @@
               </a:defRPr>
             </a:pPr>
             <a:r>
+              <a:rPr dirty="0"/>
               <a:t>Traditional Stats Systematically Undervalue Elite Contact Quality</a:t>
             </a:r>
           </a:p>
@@ -3313,7 +3323,7 @@
         </p:nvSpPr>
         <p:spPr>
           <a:xfrm>
-            <a:off x="731520" y="1097280"/>
+            <a:off x="731520" y="1407283"/>
             <a:ext cx="10058400" cy="457200"/>
           </a:xfrm>
           <a:prstGeom prst="rect">
@@ -3335,6 +3345,7 @@
               </a:defRPr>
             </a:pPr>
             <a:r>
+              <a:rPr dirty="0"/>
               <a:t>Descriptive: What happened across the league?</a:t>
             </a:r>
           </a:p>
@@ -3349,7 +3360,7 @@
         <p:spPr>
           <a:xfrm>
             <a:off x="731520" y="1737360"/>
-            <a:ext cx="5029200" cy="4114800"/>
+            <a:ext cx="3955384" cy="3600986"/>
           </a:xfrm>
           <a:prstGeom prst="rect">
             <a:avLst/>
@@ -3373,12 +3384,21 @@
               </a:defRPr>
             </a:pPr>
             <a:r>
+              <a:rPr dirty="0"/>
               <a:t>Players with barrel rates above 10% outperform their batting</a:t>
             </a:r>
-            <a:br/>
-            <a:r>
-              <a:t>average by ~45 points in xwOBA</a:t>
-            </a:r>
+            <a:br>
+              <a:rPr dirty="0"/>
+            </a:br>
+            <a:r>
+              <a:rPr dirty="0"/>
+              <a:t>average by ~45 points in </a:t>
+            </a:r>
+            <a:r>
+              <a:rPr dirty="0" err="1"/>
+              <a:t>xwOBA</a:t>
+            </a:r>
+            <a:endParaRPr dirty="0"/>
           </a:p>
           <a:p>
             <a:pPr>
@@ -3392,10 +3412,14 @@
               </a:defRPr>
             </a:pPr>
             <a:r>
+              <a:rPr dirty="0"/>
               <a:t>Barrels produce a .684 BA and 2.236 SLG vs. .292/.368</a:t>
             </a:r>
-            <a:br/>
-            <a:r>
+            <a:br>
+              <a:rPr dirty="0"/>
+            </a:br>
+            <a:r>
+              <a:rPr dirty="0"/>
               <a:t>for non-barreled contact (2026 data)</a:t>
             </a:r>
           </a:p>
@@ -3411,11 +3435,23 @@
               </a:defRPr>
             </a:pPr>
             <a:r>
+              <a:rPr dirty="0"/>
               <a:t>The scatter plot reveals a clear cluster of 'undervalued'</a:t>
             </a:r>
-            <a:br/>
-            <a:r>
-              <a:t>hitters — high xwOBA, low batting average</a:t>
+            <a:br>
+              <a:rPr dirty="0"/>
+            </a:br>
+            <a:r>
+              <a:rPr dirty="0"/>
+              <a:t>hitters — high </a:t>
+            </a:r>
+            <a:r>
+              <a:rPr dirty="0" err="1"/>
+              <a:t>xwOBA</a:t>
+            </a:r>
+            <a:r>
+              <a:rPr dirty="0"/>
+              <a:t>, low batting average</a:t>
             </a:r>
           </a:p>
           <a:p>
@@ -3430,76 +3466,49 @@
               </a:defRPr>
             </a:pPr>
             <a:r>
+              <a:rPr dirty="0"/>
               <a:t>These gaps are not random — they correlate with</a:t>
             </a:r>
-            <a:br/>
-            <a:r>
+            <a:br>
+              <a:rPr dirty="0"/>
+            </a:br>
+            <a:r>
+              <a:rPr dirty="0"/>
               <a:t>measurable batted-ball quality (exit velocity, barrel %)</a:t>
             </a:r>
           </a:p>
         </p:txBody>
       </p:sp>
-      <p:sp>
-        <p:nvSpPr>
-          <p:cNvPr id="5" name="Rectangle 4"/>
-          <p:cNvSpPr/>
+      <p:pic>
+        <p:nvPicPr>
+          <p:cNvPr id="6" name="Picture 5">
+            <a:extLst>
+              <a:ext uri="{FF2B5EF4-FFF2-40B4-BE49-F238E27FC236}">
+                <a16:creationId xmlns:a16="http://schemas.microsoft.com/office/drawing/2014/main" id="{2507DA97-CAC4-FDB9-2755-1D1924CB972F}"/>
+              </a:ext>
+            </a:extLst>
+          </p:cNvPr>
+          <p:cNvPicPr>
+            <a:picLocks noChangeAspect="1"/>
+          </p:cNvPicPr>
           <p:nvPr/>
-        </p:nvSpPr>
+        </p:nvPicPr>
+        <p:blipFill>
+          <a:blip r:embed="rId2"/>
+          <a:stretch>
+            <a:fillRect/>
+          </a:stretch>
+        </p:blipFill>
         <p:spPr>
           <a:xfrm>
-            <a:off x="6400800" y="1737360"/>
-            <a:ext cx="5029200" cy="4114800"/>
+            <a:off x="4898778" y="1864483"/>
+            <a:ext cx="6945761" cy="3681917"/>
           </a:xfrm>
           <a:prstGeom prst="rect">
             <a:avLst/>
           </a:prstGeom>
-          <a:solidFill>
-            <a:srgbClr val="F0F4F8"/>
-          </a:solidFill>
-          <a:ln w="12700">
-            <a:solidFill>
-              <a:srgbClr val="2E86C1"/>
-            </a:solidFill>
-          </a:ln>
         </p:spPr>
-        <p:style>
-          <a:lnRef idx="1">
-            <a:schemeClr val="accent1"/>
-          </a:lnRef>
-          <a:fillRef idx="3">
-            <a:schemeClr val="accent1"/>
-          </a:fillRef>
-          <a:effectRef idx="2">
-            <a:schemeClr val="accent1"/>
-          </a:effectRef>
-          <a:fontRef idx="minor">
-            <a:schemeClr val="lt1"/>
-          </a:fontRef>
-        </p:style>
-        <p:txBody>
-          <a:bodyPr rtlCol="0" anchor="ctr" wrap="square"/>
-          <a:lstStyle/>
-          <a:p>
-            <a:pPr algn="ctr">
-              <a:defRPr sz="1400">
-                <a:solidFill>
-                  <a:srgbClr val="5D6D7E"/>
-                </a:solidFill>
-              </a:defRPr>
-            </a:pPr>
-            <a:br/>
-            <a:br/>
-            <a:br/>
-            <a:r>
-              <a:t>[Screenshot: League Overview scatter plot</a:t>
-            </a:r>
-            <a:br/>
-            <a:r>
-              <a:t>from Tab 1 of dashboard]</a:t>
-            </a:r>
-          </a:p>
-        </p:txBody>
-      </p:sp>
+      </p:pic>
     </p:spTree>
   </p:cSld>
   <p:clrMapOvr>
@@ -3509,7 +3518,7 @@
 </file>
 
 <file path=ppt/slides/slide3.xml><?xml version="1.0" encoding="utf-8"?>
-<p:sld xmlns:a="http://schemas.openxmlformats.org/drawingml/2006/main" xmlns:p="http://schemas.openxmlformats.org/presentationml/2006/main" xmlns:r="http://schemas.openxmlformats.org/officeDocument/2006/relationships">
+<p:sld xmlns:a="http://schemas.openxmlformats.org/drawingml/2006/main" xmlns:r="http://schemas.openxmlformats.org/officeDocument/2006/relationships" xmlns:p="http://schemas.openxmlformats.org/presentationml/2006/main">
   <p:cSld>
     <p:bg>
       <p:bgPr>
@@ -3525,7 +3534,14 @@
         <p:cNvGrpSpPr/>
         <p:nvPr/>
       </p:nvGrpSpPr>
-      <p:grpSpPr/>
+      <p:grpSpPr>
+        <a:xfrm>
+          <a:off x="0" y="0"/>
+          <a:ext cx="0" cy="0"/>
+          <a:chOff x="0" y="0"/>
+          <a:chExt cx="0" cy="0"/>
+        </a:xfrm>
+      </p:grpSpPr>
       <p:sp>
         <p:nvSpPr>
           <p:cNvPr id="2" name="TextBox 1"/>
@@ -3605,7 +3621,7 @@
         <p:spPr>
           <a:xfrm>
             <a:off x="731520" y="1737360"/>
-            <a:ext cx="5029200" cy="4114800"/>
+            <a:ext cx="4275378" cy="4114800"/>
           </a:xfrm>
           <a:prstGeom prst="rect">
             <a:avLst/>
@@ -3629,10 +3645,22 @@
               </a:defRPr>
             </a:pPr>
             <a:r>
-              <a:t>The gap between xwOBA and batting average is largest for</a:t>
-            </a:r>
-            <a:br/>
-            <a:r>
+              <a:rPr dirty="0"/>
+              <a:t>The gap between </a:t>
+            </a:r>
+            <a:r>
+              <a:rPr dirty="0" err="1"/>
+              <a:t>xwOBA</a:t>
+            </a:r>
+            <a:r>
+              <a:rPr dirty="0"/>
+              <a:t> and batting average is largest for</a:t>
+            </a:r>
+            <a:br>
+              <a:rPr dirty="0"/>
+            </a:br>
+            <a:r>
+              <a:rPr dirty="0"/>
               <a:t>players with high exit velocity but below-average BABIP</a:t>
             </a:r>
           </a:p>
@@ -3648,10 +3676,14 @@
               </a:defRPr>
             </a:pPr>
             <a:r>
+              <a:rPr dirty="0"/>
               <a:t>Rolling 15-game trends reveal when the gap develops —</a:t>
             </a:r>
-            <a:br/>
-            <a:r>
+            <a:br>
+              <a:rPr dirty="0"/>
+            </a:br>
+            <a:r>
+              <a:rPr dirty="0"/>
               <a:t>often after a streak of hard-hit balls finding fielders</a:t>
             </a:r>
           </a:p>
@@ -3667,10 +3699,14 @@
               </a:defRPr>
             </a:pPr>
             <a:r>
+              <a:rPr dirty="0"/>
               <a:t>Contact quality charts (barrel % + exit velo) confirm the</a:t>
             </a:r>
-            <a:br/>
-            <a:r>
+            <a:br>
+              <a:rPr dirty="0"/>
+            </a:br>
+            <a:r>
+              <a:rPr dirty="0"/>
               <a:t>hitter's process is sound even when results lag</a:t>
             </a:r>
           </a:p>
@@ -3686,72 +3722,155 @@
               </a:defRPr>
             </a:pPr>
             <a:r>
+              <a:rPr dirty="0"/>
               <a:t>BABIP regresses toward ~.300 over time — players with</a:t>
             </a:r>
-            <a:br/>
-            <a:r>
+            <a:br>
+              <a:rPr dirty="0"/>
+            </a:br>
+            <a:r>
+              <a:rPr dirty="0"/>
               <a:t>low BABIP and high barrel rates are buy-low candidates</a:t>
             </a:r>
           </a:p>
         </p:txBody>
       </p:sp>
-      <p:sp>
-        <p:nvSpPr>
-          <p:cNvPr id="5" name="Rectangle 4"/>
-          <p:cNvSpPr/>
+      <p:pic>
+        <p:nvPicPr>
+          <p:cNvPr id="6" name="Picture 5">
+            <a:extLst>
+              <a:ext uri="{FF2B5EF4-FFF2-40B4-BE49-F238E27FC236}">
+                <a16:creationId xmlns:a16="http://schemas.microsoft.com/office/drawing/2014/main" id="{6A7C5FBF-81C8-F34A-E5CE-DCCF42455DA2}"/>
+              </a:ext>
+            </a:extLst>
+          </p:cNvPr>
+          <p:cNvPicPr>
+            <a:picLocks noChangeAspect="1"/>
+          </p:cNvPicPr>
           <p:nvPr/>
-        </p:nvSpPr>
+        </p:nvPicPr>
+        <p:blipFill>
+          <a:blip r:embed="rId2"/>
+          <a:stretch>
+            <a:fillRect/>
+          </a:stretch>
+        </p:blipFill>
         <p:spPr>
           <a:xfrm>
-            <a:off x="6400800" y="1737360"/>
-            <a:ext cx="5029200" cy="4114800"/>
+            <a:off x="5163014" y="1419624"/>
+            <a:ext cx="6727902" cy="2582475"/>
           </a:xfrm>
           <a:prstGeom prst="rect">
             <a:avLst/>
           </a:prstGeom>
-          <a:solidFill>
-            <a:srgbClr val="F0F4F8"/>
-          </a:solidFill>
-          <a:ln w="12700">
-            <a:solidFill>
-              <a:srgbClr val="2E86C1"/>
-            </a:solidFill>
+        </p:spPr>
+      </p:pic>
+      <p:pic>
+        <p:nvPicPr>
+          <p:cNvPr id="7" name="Picture 6">
+            <a:extLst>
+              <a:ext uri="{FF2B5EF4-FFF2-40B4-BE49-F238E27FC236}">
+                <a16:creationId xmlns:a16="http://schemas.microsoft.com/office/drawing/2014/main" id="{0229B982-A32D-6C8E-4645-AC227B44131A}"/>
+              </a:ext>
+            </a:extLst>
+          </p:cNvPr>
+          <p:cNvPicPr>
+            <a:picLocks noChangeAspect="1"/>
+          </p:cNvPicPr>
+          <p:nvPr/>
+        </p:nvPicPr>
+        <p:blipFill>
+          <a:blip r:embed="rId3"/>
+          <a:stretch>
+            <a:fillRect/>
+          </a:stretch>
+        </p:blipFill>
+        <p:spPr>
+          <a:xfrm>
+            <a:off x="5866005" y="4002099"/>
+            <a:ext cx="5321919" cy="2810710"/>
+          </a:xfrm>
+          <a:prstGeom prst="rect">
+            <a:avLst/>
+          </a:prstGeom>
+        </p:spPr>
+      </p:pic>
+      <p:cxnSp>
+        <p:nvCxnSpPr>
+          <p:cNvPr id="12" name="Straight Arrow Connector 11">
+            <a:extLst>
+              <a:ext uri="{FF2B5EF4-FFF2-40B4-BE49-F238E27FC236}">
+                <a16:creationId xmlns:a16="http://schemas.microsoft.com/office/drawing/2014/main" id="{7FC2D63D-9B32-AE9E-2A5F-B2A42595C14A}"/>
+              </a:ext>
+            </a:extLst>
+          </p:cNvPr>
+          <p:cNvCxnSpPr/>
+          <p:nvPr/>
+        </p:nvCxnSpPr>
+        <p:spPr>
+          <a:xfrm flipH="1" flipV="1">
+            <a:off x="9969190" y="3300761"/>
+            <a:ext cx="1460810" cy="947854"/>
+          </a:xfrm>
+          <a:prstGeom prst="straightConnector1">
+            <a:avLst/>
+          </a:prstGeom>
+          <a:ln>
+            <a:tailEnd type="triangle"/>
           </a:ln>
         </p:spPr>
         <p:style>
-          <a:lnRef idx="1">
+          <a:lnRef idx="2">
             <a:schemeClr val="accent1"/>
           </a:lnRef>
-          <a:fillRef idx="3">
+          <a:fillRef idx="0">
             <a:schemeClr val="accent1"/>
           </a:fillRef>
-          <a:effectRef idx="2">
+          <a:effectRef idx="1">
             <a:schemeClr val="accent1"/>
           </a:effectRef>
           <a:fontRef idx="minor">
-            <a:schemeClr val="lt1"/>
+            <a:schemeClr val="tx1"/>
           </a:fontRef>
         </p:style>
-        <p:txBody>
-          <a:bodyPr rtlCol="0" anchor="ctr" wrap="square"/>
-          <a:lstStyle/>
-          <a:p>
-            <a:pPr algn="ctr">
-              <a:defRPr sz="1400">
-                <a:solidFill>
-                  <a:srgbClr val="5D6D7E"/>
-                </a:solidFill>
-              </a:defRPr>
-            </a:pPr>
-            <a:br/>
-            <a:br/>
-            <a:br/>
-            <a:r>
-              <a:t>[Screenshot: Player Deep Dive trend chart</a:t>
-            </a:r>
-            <a:br/>
-            <a:r>
-              <a:t>from Tab 2 of dashboard]</a:t>
+      </p:cxnSp>
+      <p:sp>
+        <p:nvSpPr>
+          <p:cNvPr id="13" name="TextBox 12">
+            <a:extLst>
+              <a:ext uri="{FF2B5EF4-FFF2-40B4-BE49-F238E27FC236}">
+                <a16:creationId xmlns:a16="http://schemas.microsoft.com/office/drawing/2014/main" id="{DB9B7BBA-2050-DA21-79E7-988FC33C4126}"/>
+              </a:ext>
+            </a:extLst>
+          </p:cNvPr>
+          <p:cNvSpPr txBox="1"/>
+          <p:nvPr/>
+        </p:nvSpPr>
+        <p:spPr>
+          <a:xfrm>
+            <a:off x="11187924" y="4324443"/>
+            <a:ext cx="910377" cy="646331"/>
+          </a:xfrm>
+          <a:prstGeom prst="rect">
+            <a:avLst/>
+          </a:prstGeom>
+          <a:noFill/>
+        </p:spPr>
+        <p:txBody>
+          <a:bodyPr wrap="none" rtlCol="0">
+            <a:spAutoFit/>
+          </a:bodyPr>
+          <a:lstStyle/>
+          <a:p>
+            <a:r>
+              <a:rPr lang="en-US" dirty="0"/>
+              <a:t>Positive</a:t>
+            </a:r>
+          </a:p>
+          <a:p>
+            <a:r>
+              <a:rPr lang="en-US" dirty="0"/>
+              <a:t>Gap</a:t>
             </a:r>
           </a:p>
         </p:txBody>
@@ -3765,7 +3884,7 @@
 </file>
 
 <file path=ppt/slides/slide4.xml><?xml version="1.0" encoding="utf-8"?>
-<p:sld xmlns:a="http://schemas.openxmlformats.org/drawingml/2006/main" xmlns:p="http://schemas.openxmlformats.org/presentationml/2006/main" xmlns:r="http://schemas.openxmlformats.org/officeDocument/2006/relationships">
+<p:sld xmlns:a="http://schemas.openxmlformats.org/drawingml/2006/main" xmlns:r="http://schemas.openxmlformats.org/officeDocument/2006/relationships" xmlns:p="http://schemas.openxmlformats.org/presentationml/2006/main">
   <p:cSld>
     <p:bg>
       <p:bgPr>
@@ -3781,7 +3900,14 @@
         <p:cNvGrpSpPr/>
         <p:nvPr/>
       </p:nvGrpSpPr>
-      <p:grpSpPr/>
+      <p:grpSpPr>
+        <a:xfrm>
+          <a:off x="0" y="0"/>
+          <a:ext cx="0" cy="0"/>
+          <a:chOff x="0" y="0"/>
+          <a:chExt cx="0" cy="0"/>
+        </a:xfrm>
+      </p:grpSpPr>
       <p:sp>
         <p:nvSpPr>
           <p:cNvPr id="2" name="TextBox 1"/>
@@ -3958,7 +4084,7 @@
           </a:fontRef>
         </p:style>
         <p:txBody>
-          <a:bodyPr rtlCol="0" anchor="ctr" wrap="square"/>
+          <a:bodyPr wrap="square" rtlCol="0" anchor="ctr"/>
           <a:lstStyle/>
           <a:p>
             <a:pPr algn="ctr">
@@ -4043,7 +4169,7 @@
 </file>
 
 <file path=ppt/slides/slide5.xml><?xml version="1.0" encoding="utf-8"?>
-<p:sld xmlns:a="http://schemas.openxmlformats.org/drawingml/2006/main" xmlns:p="http://schemas.openxmlformats.org/presentationml/2006/main" xmlns:r="http://schemas.openxmlformats.org/officeDocument/2006/relationships">
+<p:sld xmlns:a="http://schemas.openxmlformats.org/drawingml/2006/main" xmlns:r="http://schemas.openxmlformats.org/officeDocument/2006/relationships" xmlns:p="http://schemas.openxmlformats.org/presentationml/2006/main">
   <p:cSld>
     <p:bg>
       <p:bgPr>
@@ -4059,7 +4185,14 @@
         <p:cNvGrpSpPr/>
         <p:nvPr/>
       </p:nvGrpSpPr>
-      <p:grpSpPr/>
+      <p:grpSpPr>
+        <a:xfrm>
+          <a:off x="0" y="0"/>
+          <a:ext cx="0" cy="0"/>
+          <a:chOff x="0" y="0"/>
+          <a:chExt cx="0" cy="0"/>
+        </a:xfrm>
+      </p:grpSpPr>
       <p:sp>
         <p:nvSpPr>
           <p:cNvPr id="2" name="TextBox 1"/>
@@ -4090,6 +4223,7 @@
               </a:defRPr>
             </a:pPr>
             <a:r>
+              <a:rPr dirty="0"/>
               <a:t>End-to-End Pipeline: From Raw APIs to Actionable Dashboard</a:t>
             </a:r>
           </a:p>
@@ -4103,7 +4237,7 @@
         </p:nvSpPr>
         <p:spPr>
           <a:xfrm>
-            <a:off x="731520" y="1097280"/>
+            <a:off x="731520" y="1376061"/>
             <a:ext cx="10058400" cy="457200"/>
           </a:xfrm>
           <a:prstGeom prst="rect">
@@ -4125,6 +4259,7 @@
               </a:defRPr>
             </a:pPr>
             <a:r>
+              <a:rPr dirty="0"/>
               <a:t>Architecture &amp; Tech Stack</a:t>
             </a:r>
           </a:p>
@@ -4139,7 +4274,7 @@
         <p:spPr>
           <a:xfrm>
             <a:off x="731520" y="1737360"/>
-            <a:ext cx="5029200" cy="4572000"/>
+            <a:ext cx="9250680" cy="3375283"/>
           </a:xfrm>
           <a:prstGeom prst="rect">
             <a:avLst/>
@@ -4163,10 +4298,22 @@
               </a:defRPr>
             </a:pPr>
             <a:r>
-              <a:t>Extract: MLB Stats API + Pybaseball (Statcast)</a:t>
-            </a:r>
-            <a:br/>
-            <a:r>
+              <a:rPr dirty="0"/>
+              <a:t>Extract: MLB Stats API + Pybaseball (</a:t>
+            </a:r>
+            <a:r>
+              <a:rPr dirty="0" err="1"/>
+              <a:t>Statcast</a:t>
+            </a:r>
+            <a:r>
+              <a:rPr dirty="0"/>
+              <a:t>)</a:t>
+            </a:r>
+            <a:br>
+              <a:rPr dirty="0"/>
+            </a:br>
+            <a:r>
+              <a:rPr dirty="0"/>
               <a:t>pull player stats, game logs, and batted-ball data</a:t>
             </a:r>
           </a:p>
@@ -4182,10 +4329,14 @@
               </a:defRPr>
             </a:pPr>
             <a:r>
+              <a:rPr dirty="0"/>
               <a:t>Load: Python scripts write to Snowflake RAW schema</a:t>
             </a:r>
-            <a:br/>
-            <a:r>
+            <a:br>
+              <a:rPr dirty="0"/>
+            </a:br>
+            <a:r>
+              <a:rPr dirty="0"/>
               <a:t>via snowflake-connector-python</a:t>
             </a:r>
           </a:p>
@@ -4201,10 +4352,22 @@
               </a:defRPr>
             </a:pPr>
             <a:r>
-              <a:t>Transform: dbt builds staging views and mart tables</a:t>
-            </a:r>
-            <a:br/>
-            <a:r>
+              <a:rPr dirty="0"/>
+              <a:t>Transform: </a:t>
+            </a:r>
+            <a:r>
+              <a:rPr dirty="0" err="1"/>
+              <a:t>dbt</a:t>
+            </a:r>
+            <a:r>
+              <a:rPr dirty="0"/>
+              <a:t> builds staging views and mart tables</a:t>
+            </a:r>
+            <a:br>
+              <a:rPr dirty="0"/>
+            </a:br>
+            <a:r>
+              <a:rPr dirty="0"/>
               <a:t>(star schema: 2 facts + 4 dimensions)</a:t>
             </a:r>
           </a:p>
@@ -4220,10 +4383,22 @@
               </a:defRPr>
             </a:pPr>
             <a:r>
-              <a:t>Present: Streamlit dashboard with Plotly charts</a:t>
-            </a:r>
-            <a:br/>
-            <a:r>
+              <a:rPr dirty="0"/>
+              <a:t>Present: </a:t>
+            </a:r>
+            <a:r>
+              <a:rPr dirty="0" err="1"/>
+              <a:t>Streamlit</a:t>
+            </a:r>
+            <a:r>
+              <a:rPr dirty="0"/>
+              <a:t> dashboard with Plotly charts</a:t>
+            </a:r>
+            <a:br>
+              <a:rPr dirty="0"/>
+            </a:br>
+            <a:r>
+              <a:rPr dirty="0"/>
               <a:t>deployed to Community Cloud</a:t>
             </a:r>
           </a:p>
@@ -4239,10 +4414,14 @@
               </a:defRPr>
             </a:pPr>
             <a:r>
+              <a:rPr dirty="0"/>
               <a:t>Knowledge Base: 16 sources scraped from FanGraphs,</a:t>
             </a:r>
-            <a:br/>
-            <a:r>
+            <a:br>
+              <a:rPr dirty="0"/>
+            </a:br>
+            <a:r>
+              <a:rPr dirty="0"/>
               <a:t>Baseball Savant, BP → 4 synthesized wiki pages</a:t>
             </a:r>
           </a:p>
@@ -4258,76 +4437,49 @@
               </a:defRPr>
             </a:pPr>
             <a:r>
+              <a:rPr dirty="0"/>
               <a:t>Orchestrate: GitHub Actions runs daily ELT</a:t>
             </a:r>
-            <a:br/>
-            <a:r>
+            <a:br>
+              <a:rPr dirty="0"/>
+            </a:br>
+            <a:r>
+              <a:rPr dirty="0"/>
               <a:t>and weekly knowledge base re-scrape</a:t>
             </a:r>
           </a:p>
         </p:txBody>
       </p:sp>
-      <p:sp>
-        <p:nvSpPr>
-          <p:cNvPr id="5" name="Rectangle 4"/>
-          <p:cNvSpPr/>
+      <p:pic>
+        <p:nvPicPr>
+          <p:cNvPr id="8" name="Picture 7">
+            <a:extLst>
+              <a:ext uri="{FF2B5EF4-FFF2-40B4-BE49-F238E27FC236}">
+                <a16:creationId xmlns:a16="http://schemas.microsoft.com/office/drawing/2014/main" id="{DD505CFF-DA02-9010-5949-917DC5D37133}"/>
+              </a:ext>
+            </a:extLst>
+          </p:cNvPr>
+          <p:cNvPicPr>
+            <a:picLocks noChangeAspect="1"/>
+          </p:cNvPicPr>
           <p:nvPr/>
-        </p:nvSpPr>
+        </p:nvPicPr>
+        <p:blipFill>
+          <a:blip r:embed="rId2"/>
+          <a:stretch>
+            <a:fillRect/>
+          </a:stretch>
+        </p:blipFill>
         <p:spPr>
           <a:xfrm>
-            <a:off x="6400800" y="1737360"/>
-            <a:ext cx="5029200" cy="4114800"/>
+            <a:off x="5040351" y="2873554"/>
+            <a:ext cx="6950927" cy="2239089"/>
           </a:xfrm>
           <a:prstGeom prst="rect">
             <a:avLst/>
           </a:prstGeom>
-          <a:solidFill>
-            <a:srgbClr val="F0F4F8"/>
-          </a:solidFill>
-          <a:ln w="12700">
-            <a:solidFill>
-              <a:srgbClr val="2E86C1"/>
-            </a:solidFill>
-          </a:ln>
         </p:spPr>
-        <p:style>
-          <a:lnRef idx="1">
-            <a:schemeClr val="accent1"/>
-          </a:lnRef>
-          <a:fillRef idx="3">
-            <a:schemeClr val="accent1"/>
-          </a:fillRef>
-          <a:effectRef idx="2">
-            <a:schemeClr val="accent1"/>
-          </a:effectRef>
-          <a:fontRef idx="minor">
-            <a:schemeClr val="lt1"/>
-          </a:fontRef>
-        </p:style>
-        <p:txBody>
-          <a:bodyPr rtlCol="0" anchor="ctr" wrap="square"/>
-          <a:lstStyle/>
-          <a:p>
-            <a:pPr algn="ctr">
-              <a:defRPr sz="1400">
-                <a:solidFill>
-                  <a:srgbClr val="5D6D7E"/>
-                </a:solidFill>
-              </a:defRPr>
-            </a:pPr>
-            <a:br/>
-            <a:br/>
-            <a:br/>
-            <a:r>
-              <a:t>[Screenshot: Pipeline diagram</a:t>
-            </a:r>
-            <a:br/>
-            <a:r>
-              <a:t>from README on GitHub]</a:t>
-            </a:r>
-          </a:p>
-        </p:txBody>
-      </p:sp>
+      </p:pic>
     </p:spTree>
   </p:cSld>
   <p:clrMapOvr>

</xml_diff>